<commit_message>
deck: update results slides 7-9 with emlddmm-4x numbers
Comparison, major-region, and disease-region slides now reflect the 3-scale
(16x/8x/4x) emlddmm results (improved NCC/edge/MI/RMSE on both samples).

Co-Authored-By: Claude Opus 4.8 <noreply@anthropic.com>
</commit_message>
<xml_diff>
--- a/Brain_Registration_Pipeline_and_Comparison.pptx
+++ b/Brain_Registration_Pipeline_and_Comparison.pptx
@@ -4575,14 +4575,14 @@
       <p:grpSpPr/>
       <p:pic>
         <p:nvPicPr>
-          <p:cNvPr id="2" name="Picture 1" descr="themed_07.png"/>
+          <p:cNvPr id="2" name="Picture 1" descr="slide_07_new.png"/>
           <p:cNvPicPr>
             <a:picLocks noChangeAspect="1"/>
           </p:cNvPicPr>
           <p:nvPr/>
         </p:nvPicPr>
         <p:blipFill>
-          <a:blip r:embed="rId2"/>
+          <a:blip r:embed="rId3"/>
           <a:stretch>
             <a:fillRect/>
           </a:stretch>
@@ -4617,14 +4617,14 @@
       <p:grpSpPr/>
       <p:pic>
         <p:nvPicPr>
-          <p:cNvPr id="2" name="Picture 1" descr="themed_08.png"/>
+          <p:cNvPr id="2" name="Picture 1" descr="slide_08_new.png"/>
           <p:cNvPicPr>
             <a:picLocks noChangeAspect="1"/>
           </p:cNvPicPr>
           <p:nvPr/>
         </p:nvPicPr>
         <p:blipFill>
-          <a:blip r:embed="rId2"/>
+          <a:blip r:embed="rId3"/>
           <a:stretch>
             <a:fillRect/>
           </a:stretch>
@@ -4659,14 +4659,14 @@
       <p:grpSpPr/>
       <p:pic>
         <p:nvPicPr>
-          <p:cNvPr id="2" name="Picture 1" descr="themed_09.png"/>
+          <p:cNvPr id="2" name="Picture 1" descr="slide_09_new.png"/>
           <p:cNvPicPr>
             <a:picLocks noChangeAspect="1"/>
           </p:cNvPicPr>
           <p:nvPr/>
         </p:nvPicPr>
         <p:blipFill>
-          <a:blip r:embed="rId2"/>
+          <a:blip r:embed="rId3"/>
           <a:stretch>
             <a:fillRect/>
           </a:stretch>

</xml_diff>